<commit_message>
Preserve original English wording
Co-authored-by: Copilot App <223556219+Copilot@users.noreply.github.com>
</commit_message>
<xml_diff>
--- a/light-party.pptx
+++ b/light-party.pptx
@@ -671,7 +671,7 @@
           </a:p>
           <a:p>
             <a:r>
-              <a:t>1. 大家平時諗起萬聖節，可能就係扮靚、食糖果、同朋友去派對。</a:t>
+              <a:t>1. 大家平時諗起萬聖節，可能就係扮靚、食糖果、同朋友去 Party。</a:t>
             </a:r>
           </a:p>
           <a:p>
@@ -793,7 +793,7 @@
           </a:p>
           <a:p>
             <a:r>
-              <a:t>2. 第二層：西方教會嘅諸聖節係 11 月 1 日；前一晚稱 諸聖節前夕，名稱後來成為 萬聖節。</a:t>
+              <a:t>2. 第二層：西方教會嘅諸聖節係 11 月 1 日；前一晚稱 All Hallows' Eve，名稱後來成為 Halloween。</a:t>
             </a:r>
           </a:p>
           <a:p>
@@ -2853,7 +2853,7 @@
           </a:p>
           <a:p>
             <a:r>
-              <a:t>2. 歷史概述參考 歷史資料 嘅 萬聖節歷史簡介；唔同民俗之間嘅具體關係仲有學者討論，唔會宣稱只有單一起源。</a:t>
+              <a:t>2. 歷史概述參考 HISTORY 嘅 History of Halloween；唔同民俗之間嘅具體關係仲有學者討論，唔會宣稱只有單一起源。</a:t>
             </a:r>
           </a:p>
           <a:p>
@@ -2992,7 +2992,7 @@
           <a:p/>
           <a:p>
             <a:r>
-              <a:t>轉去下一頁：第一題：討糖果最初係咪為咗攞朱古力？</a:t>
+              <a:t>轉去下一頁：第一題：討糖果最初就係為咗攞朱古力嗎？</a:t>
             </a:r>
           </a:p>
           <a:p>
@@ -3199,7 +3199,7 @@
           </a:p>
           <a:p>
             <a:r>
-              <a:t>呢頁重點：用審慎嘅講法交代祈禱換取靈魂餅、化裝表演同現代討糖果習俗之間嘅關係。</a:t>
+              <a:t>呢頁重點：用較審慎嘅講法交代 souling、guising 同現代討糖果嘅關係。</a:t>
             </a:r>
           </a:p>
           <a:p/>
@@ -3215,7 +3215,7 @@
           </a:p>
           <a:p>
             <a:r>
-              <a:t>2. 相關前身之一係為亡者祈禱，換取食物或「靈魂餅」；另一種做法係化裝上門表演，換取食物或小禮物。</a:t>
+              <a:t>2. 相關前身包括 souling：以為亡者祈禱換取食物或「靈魂餅」；同埋 guising：裝扮後表演換取食物或小禮物。</a:t>
             </a:r>
           </a:p>
           <a:p>
@@ -3333,7 +3333,7 @@
           </a:p>
           <a:p>
             <a:r>
-              <a:t>1. 讀題：「傑克燈 最早就係用南瓜做嘅？」</a:t>
+              <a:t>1. 讀題：「Jack-o'-lantern 最早就係用南瓜做嘅？」</a:t>
             </a:r>
           </a:p>
           <a:p>
@@ -6733,7 +6733,7 @@
       <p:grpSpPr/>
       <p:sp>
         <p:nvSpPr>
-          <p:cNvPr id="2" name="Text: 光明派對  /  青少年團契"/>
+          <p:cNvPr id="2" name="Text: LIGHT PARTY  /  青少年團契"/>
           <p:cNvSpPr txBox="1"/>
           <p:nvPr/>
         </p:nvSpPr>
@@ -6772,7 +6772,7 @@
                 <a:latin typeface="Microsoft JhengHei"/>
                 <a:ea typeface="Microsoft JhengHei"/>
               </a:rPr>
-              <a:t>光明派對  /  青少年團契</a:t>
+              <a:t>LIGHT PARTY  /  青少年團契</a:t>
             </a:r>
           </a:p>
         </p:txBody>
@@ -7600,7 +7600,7 @@
       </p:cxnSp>
       <p:sp>
         <p:nvSpPr>
-          <p:cNvPr id="23" name="Text: 光明&#10;派對"/>
+          <p:cNvPr id="23" name="Text: LIGHT&#10;PARTY"/>
           <p:cNvSpPr txBox="1"/>
           <p:nvPr/>
         </p:nvSpPr>
@@ -7639,7 +7639,7 @@
                 <a:latin typeface="PMingLiU"/>
                 <a:ea typeface="PMingLiU"/>
               </a:rPr>
-              <a:t>光明</a:t>
+              <a:t>LIGHT</a:t>
             </a:r>
           </a:p>
           <a:p>
@@ -7662,7 +7662,7 @@
                 <a:latin typeface="PMingLiU"/>
                 <a:ea typeface="PMingLiU"/>
               </a:rPr>
-              <a:t>派對</a:t>
+              <a:t>PARTY</a:t>
             </a:r>
           </a:p>
         </p:txBody>
@@ -7695,7 +7695,7 @@
       <p:grpSpPr/>
       <p:sp>
         <p:nvSpPr>
-          <p:cNvPr id="2" name="Text: 光明派對  /  青少年團契"/>
+          <p:cNvPr id="2" name="Text: LIGHT PARTY  /  青少年團契"/>
           <p:cNvSpPr txBox="1"/>
           <p:nvPr/>
         </p:nvSpPr>
@@ -7734,7 +7734,7 @@
                 <a:latin typeface="Microsoft JhengHei"/>
                 <a:ea typeface="Microsoft JhengHei"/>
               </a:rPr>
-              <a:t>光明派對  /  青少年團契</a:t>
+              <a:t>LIGHT PARTY  /  青少年團契</a:t>
             </a:r>
           </a:p>
         </p:txBody>
@@ -8090,7 +8090,7 @@
       <p:grpSpPr/>
       <p:sp>
         <p:nvSpPr>
-          <p:cNvPr id="2" name="Text: 光明派對  /  青少年團契"/>
+          <p:cNvPr id="2" name="Text: LIGHT PARTY  /  青少年團契"/>
           <p:cNvSpPr txBox="1"/>
           <p:nvPr/>
         </p:nvSpPr>
@@ -8129,7 +8129,7 @@
                 <a:latin typeface="Microsoft JhengHei"/>
                 <a:ea typeface="Microsoft JhengHei"/>
               </a:rPr>
-              <a:t>光明派對  /  青少年團契</a:t>
+              <a:t>LIGHT PARTY  /  青少年團契</a:t>
             </a:r>
           </a:p>
         </p:txBody>
@@ -8471,7 +8471,7 @@
       </p:sp>
       <p:sp>
         <p:nvSpPr>
-          <p:cNvPr id="11" name="Text: 薩溫節 薩溫節"/>
+          <p:cNvPr id="11" name="Text: 薩溫節 Samhain"/>
           <p:cNvSpPr txBox="1"/>
           <p:nvPr/>
         </p:nvSpPr>
@@ -8510,7 +8510,7 @@
                 <a:latin typeface="PMingLiU"/>
                 <a:ea typeface="PMingLiU"/>
               </a:rPr>
-              <a:t>薩溫節 薩溫節</a:t>
+              <a:t>薩溫節 Samhain</a:t>
             </a:r>
           </a:p>
         </p:txBody>
@@ -8736,7 +8736,7 @@
       </p:sp>
       <p:sp>
         <p:nvSpPr>
-          <p:cNvPr id="16" name="Text: 11 月 1 日為諸聖節。&#10;前一晚 諸聖節前夕，&#10;後來成為 萬聖"/>
+          <p:cNvPr id="16" name="Text: 11 月 1 日為諸聖節。&#10;前一晚 All Hallows' E"/>
           <p:cNvSpPr txBox="1"/>
           <p:nvPr/>
         </p:nvSpPr>
@@ -8798,7 +8798,7 @@
                 <a:latin typeface="Microsoft JhengHei"/>
                 <a:ea typeface="Microsoft JhengHei"/>
               </a:rPr>
-              <a:t>前一晚 諸聖節前夕，</a:t>
+              <a:t>前一晚 All Hallows' Eve，</a:t>
             </a:r>
           </a:p>
           <a:p>
@@ -8821,7 +8821,7 @@
                 <a:latin typeface="Microsoft JhengHei"/>
                 <a:ea typeface="Microsoft JhengHei"/>
               </a:rPr>
-              <a:t>後來成為 萬聖節。</a:t>
+              <a:t>後來成為 Halloween。</a:t>
             </a:r>
           </a:p>
         </p:txBody>
@@ -9047,7 +9047,7 @@
       </p:sp>
       <p:sp>
         <p:nvSpPr>
-          <p:cNvPr id="21" name="Text: 歷史記述 ≠ 證實鬼魂存在｜參考：歷史資料，萬聖節歷史簡介"/>
+          <p:cNvPr id="21" name="Text: 歷史記述 ≠ 證實鬼魂存在｜參考：HISTORY，History"/>
           <p:cNvSpPr txBox="1"/>
           <p:nvPr/>
         </p:nvSpPr>
@@ -9087,7 +9087,7 @@
                 <a:ea typeface="Microsoft JhengHei"/>
                 <a:hlinkClick r:id="rId2"/>
               </a:rPr>
-              <a:t>歷史記述 ≠ 證實鬼魂存在｜參考：歷史資料，萬聖節歷史簡介</a:t>
+              <a:t>歷史記述 ≠ 證實鬼魂存在｜參考：HISTORY，History of Halloween</a:t>
             </a:r>
           </a:p>
         </p:txBody>
@@ -9120,7 +9120,7 @@
       <p:grpSpPr/>
       <p:sp>
         <p:nvSpPr>
-          <p:cNvPr id="2" name="Text: 光明派對  /  青少年團契"/>
+          <p:cNvPr id="2" name="Text: LIGHT PARTY  /  青少年團契"/>
           <p:cNvSpPr txBox="1"/>
           <p:nvPr/>
         </p:nvSpPr>
@@ -9159,7 +9159,7 @@
                 <a:latin typeface="Microsoft JhengHei"/>
                 <a:ea typeface="Microsoft JhengHei"/>
               </a:rPr>
-              <a:t>光明派對  /  青少年團契</a:t>
+              <a:t>LIGHT PARTY  /  青少年團契</a:t>
             </a:r>
           </a:p>
         </p:txBody>
@@ -10080,7 +10080,7 @@
       <p:grpSpPr/>
       <p:sp>
         <p:nvSpPr>
-          <p:cNvPr id="2" name="Text: 光明派對  /  青少年團契"/>
+          <p:cNvPr id="2" name="Text: LIGHT PARTY  /  青少年團契"/>
           <p:cNvSpPr txBox="1"/>
           <p:nvPr/>
         </p:nvSpPr>
@@ -10119,7 +10119,7 @@
                 <a:latin typeface="Microsoft JhengHei"/>
                 <a:ea typeface="Microsoft JhengHei"/>
               </a:rPr>
-              <a:t>光明派對  /  青少年團契</a:t>
+              <a:t>LIGHT PARTY  /  青少年團契</a:t>
             </a:r>
           </a:p>
         </p:txBody>
@@ -10798,7 +10798,7 @@
       <p:grpSpPr/>
       <p:sp>
         <p:nvSpPr>
-          <p:cNvPr id="2" name="Text: 光明派對  /  青少年團契"/>
+          <p:cNvPr id="2" name="Text: LIGHT PARTY  /  青少年團契"/>
           <p:cNvSpPr txBox="1"/>
           <p:nvPr/>
         </p:nvSpPr>
@@ -10837,7 +10837,7 @@
                 <a:latin typeface="Microsoft JhengHei"/>
                 <a:ea typeface="Microsoft JhengHei"/>
               </a:rPr>
-              <a:t>光明派對  /  青少年團契</a:t>
+              <a:t>LIGHT PARTY  /  青少年團契</a:t>
             </a:r>
           </a:p>
         </p:txBody>
@@ -11539,7 +11539,7 @@
       <p:grpSpPr/>
       <p:sp>
         <p:nvSpPr>
-          <p:cNvPr id="2" name="Text: 光明派對  /  青少年團契"/>
+          <p:cNvPr id="2" name="Text: LIGHT PARTY  /  青少年團契"/>
           <p:cNvSpPr txBox="1"/>
           <p:nvPr/>
         </p:nvSpPr>
@@ -11578,7 +11578,7 @@
                 <a:latin typeface="Microsoft JhengHei"/>
                 <a:ea typeface="Microsoft JhengHei"/>
               </a:rPr>
-              <a:t>光明派對  /  青少年團契</a:t>
+              <a:t>LIGHT PARTY  /  青少年團契</a:t>
             </a:r>
           </a:p>
         </p:txBody>
@@ -12257,7 +12257,7 @@
       <p:grpSpPr/>
       <p:sp>
         <p:nvSpPr>
-          <p:cNvPr id="2" name="Text: 光明派對  /  青少年團契"/>
+          <p:cNvPr id="2" name="Text: LIGHT PARTY  /  青少年團契"/>
           <p:cNvSpPr txBox="1"/>
           <p:nvPr/>
         </p:nvSpPr>
@@ -12296,7 +12296,7 @@
                 <a:latin typeface="Microsoft JhengHei"/>
                 <a:ea typeface="Microsoft JhengHei"/>
               </a:rPr>
-              <a:t>光明派對  /  青少年團契</a:t>
+              <a:t>LIGHT PARTY  /  青少年團契</a:t>
             </a:r>
           </a:p>
         </p:txBody>
@@ -13217,7 +13217,7 @@
       <p:grpSpPr/>
       <p:sp>
         <p:nvSpPr>
-          <p:cNvPr id="2" name="Text: 光明派對  /  青少年團契"/>
+          <p:cNvPr id="2" name="Text: LIGHT PARTY  /  青少年團契"/>
           <p:cNvSpPr txBox="1"/>
           <p:nvPr/>
         </p:nvSpPr>
@@ -13256,7 +13256,7 @@
                 <a:latin typeface="Microsoft JhengHei"/>
                 <a:ea typeface="Microsoft JhengHei"/>
               </a:rPr>
-              <a:t>光明派對  /  青少年團契</a:t>
+              <a:t>LIGHT PARTY  /  青少年團契</a:t>
             </a:r>
           </a:p>
         </p:txBody>
@@ -13924,7 +13924,7 @@
       <p:grpSpPr/>
       <p:sp>
         <p:nvSpPr>
-          <p:cNvPr id="2" name="Text: 光明派對  /  青少年團契"/>
+          <p:cNvPr id="2" name="Text: LIGHT PARTY  /  青少年團契"/>
           <p:cNvSpPr txBox="1"/>
           <p:nvPr/>
         </p:nvSpPr>
@@ -13963,7 +13963,7 @@
                 <a:latin typeface="Microsoft JhengHei"/>
                 <a:ea typeface="Microsoft JhengHei"/>
               </a:rPr>
-              <a:t>光明派對  /  青少年團契</a:t>
+              <a:t>LIGHT PARTY  /  青少年團契</a:t>
             </a:r>
           </a:p>
         </p:txBody>
@@ -14953,7 +14953,7 @@
       <p:grpSpPr/>
       <p:sp>
         <p:nvSpPr>
-          <p:cNvPr id="2" name="Text: 光明派對  /  青少年團契"/>
+          <p:cNvPr id="2" name="Text: LIGHT PARTY  /  青少年團契"/>
           <p:cNvSpPr txBox="1"/>
           <p:nvPr/>
         </p:nvSpPr>
@@ -14992,7 +14992,7 @@
                 <a:latin typeface="Microsoft JhengHei"/>
                 <a:ea typeface="Microsoft JhengHei"/>
               </a:rPr>
-              <a:t>光明派對  /  青少年團契</a:t>
+              <a:t>LIGHT PARTY  /  青少年團契</a:t>
             </a:r>
           </a:p>
         </p:txBody>
@@ -15394,7 +15394,7 @@
       <p:grpSpPr/>
       <p:sp>
         <p:nvSpPr>
-          <p:cNvPr id="2" name="Text: 光明派對  /  青少年團契"/>
+          <p:cNvPr id="2" name="Text: LIGHT PARTY  /  青少年團契"/>
           <p:cNvSpPr txBox="1"/>
           <p:nvPr/>
         </p:nvSpPr>
@@ -15433,7 +15433,7 @@
                 <a:latin typeface="Microsoft JhengHei"/>
                 <a:ea typeface="Microsoft JhengHei"/>
               </a:rPr>
-              <a:t>光明派對  /  青少年團契</a:t>
+              <a:t>LIGHT PARTY  /  青少年團契</a:t>
             </a:r>
           </a:p>
         </p:txBody>
@@ -15602,7 +15602,7 @@
       </p:sp>
       <p:sp>
         <p:nvSpPr>
-          <p:cNvPr id="7" name="Text: 今日流程"/>
+          <p:cNvPr id="7" name="Text: TODAY'S ROUTE"/>
           <p:cNvSpPr txBox="1"/>
           <p:nvPr/>
         </p:nvSpPr>
@@ -15641,7 +15641,7 @@
                 <a:latin typeface="Microsoft JhengHei"/>
                 <a:ea typeface="Microsoft JhengHei"/>
               </a:rPr>
-              <a:t>今日流程</a:t>
+              <a:t>TODAY'S ROUTE</a:t>
             </a:r>
           </a:p>
         </p:txBody>
@@ -16631,7 +16631,7 @@
       <p:grpSpPr/>
       <p:sp>
         <p:nvSpPr>
-          <p:cNvPr id="2" name="Text: 光明派對  /  青少年團契"/>
+          <p:cNvPr id="2" name="Text: LIGHT PARTY  /  青少年團契"/>
           <p:cNvSpPr txBox="1"/>
           <p:nvPr/>
         </p:nvSpPr>
@@ -16670,7 +16670,7 @@
                 <a:latin typeface="Microsoft JhengHei"/>
                 <a:ea typeface="Microsoft JhengHei"/>
               </a:rPr>
-              <a:t>光明派對  /  青少年團契</a:t>
+              <a:t>LIGHT PARTY  /  青少年團契</a:t>
             </a:r>
           </a:p>
         </p:txBody>
@@ -17026,7 +17026,7 @@
       <p:grpSpPr/>
       <p:sp>
         <p:nvSpPr>
-          <p:cNvPr id="2" name="Text: 光明派對  /  青少年團契"/>
+          <p:cNvPr id="2" name="Text: LIGHT PARTY  /  青少年團契"/>
           <p:cNvSpPr txBox="1"/>
           <p:nvPr/>
         </p:nvSpPr>
@@ -17065,7 +17065,7 @@
                 <a:latin typeface="Microsoft JhengHei"/>
                 <a:ea typeface="Microsoft JhengHei"/>
               </a:rPr>
-              <a:t>光明派對  /  青少年團契</a:t>
+              <a:t>LIGHT PARTY  /  青少年團契</a:t>
             </a:r>
           </a:p>
         </p:txBody>
@@ -17986,7 +17986,7 @@
       <p:grpSpPr/>
       <p:sp>
         <p:nvSpPr>
-          <p:cNvPr id="2" name="Text: 光明派對  /  青少年團契"/>
+          <p:cNvPr id="2" name="Text: LIGHT PARTY  /  青少年團契"/>
           <p:cNvSpPr txBox="1"/>
           <p:nvPr/>
         </p:nvSpPr>
@@ -18025,7 +18025,7 @@
                 <a:latin typeface="Microsoft JhengHei"/>
                 <a:ea typeface="Microsoft JhengHei"/>
               </a:rPr>
-              <a:t>光明派對  /  青少年團契</a:t>
+              <a:t>LIGHT PARTY  /  青少年團契</a:t>
             </a:r>
           </a:p>
         </p:txBody>
@@ -18496,7 +18496,7 @@
       <p:grpSpPr/>
       <p:sp>
         <p:nvSpPr>
-          <p:cNvPr id="2" name="Text: 光明派對  /  青少年團契"/>
+          <p:cNvPr id="2" name="Text: LIGHT PARTY  /  青少年團契"/>
           <p:cNvSpPr txBox="1"/>
           <p:nvPr/>
         </p:nvSpPr>
@@ -18535,7 +18535,7 @@
                 <a:latin typeface="Microsoft JhengHei"/>
                 <a:ea typeface="Microsoft JhengHei"/>
               </a:rPr>
-              <a:t>光明派對  /  青少年團契</a:t>
+              <a:t>LIGHT PARTY  /  青少年團契</a:t>
             </a:r>
           </a:p>
         </p:txBody>
@@ -19410,7 +19410,7 @@
       <p:grpSpPr/>
       <p:sp>
         <p:nvSpPr>
-          <p:cNvPr id="2" name="Text: 光明派對  /  青少年團契"/>
+          <p:cNvPr id="2" name="Text: LIGHT PARTY  /  青少年團契"/>
           <p:cNvSpPr txBox="1"/>
           <p:nvPr/>
         </p:nvSpPr>
@@ -19449,7 +19449,7 @@
                 <a:latin typeface="Microsoft JhengHei"/>
                 <a:ea typeface="Microsoft JhengHei"/>
               </a:rPr>
-              <a:t>光明派對  /  青少年團契</a:t>
+              <a:t>LIGHT PARTY  /  青少年團契</a:t>
             </a:r>
           </a:p>
         </p:txBody>
@@ -19710,7 +19710,7 @@
       </p:sp>
       <p:sp>
         <p:nvSpPr>
-          <p:cNvPr id="9" name="Text: 光明派對"/>
+          <p:cNvPr id="9" name="Text: LIGHT PARTY"/>
           <p:cNvSpPr txBox="1"/>
           <p:nvPr/>
         </p:nvSpPr>
@@ -19749,7 +19749,7 @@
                 <a:latin typeface="PMingLiU"/>
                 <a:ea typeface="PMingLiU"/>
               </a:rPr>
-              <a:t>光明派對</a:t>
+              <a:t>LIGHT PARTY</a:t>
             </a:r>
           </a:p>
         </p:txBody>
@@ -20326,7 +20326,7 @@
       <p:grpSpPr/>
       <p:sp>
         <p:nvSpPr>
-          <p:cNvPr id="2" name="Text: 光明派對  /  青少年團契"/>
+          <p:cNvPr id="2" name="Text: LIGHT PARTY  /  青少年團契"/>
           <p:cNvSpPr txBox="1"/>
           <p:nvPr/>
         </p:nvSpPr>
@@ -20365,7 +20365,7 @@
                 <a:latin typeface="Microsoft JhengHei"/>
                 <a:ea typeface="Microsoft JhengHei"/>
               </a:rPr>
-              <a:t>光明派對  /  青少年團契</a:t>
+              <a:t>LIGHT PARTY  /  青少年團契</a:t>
             </a:r>
           </a:p>
         </p:txBody>
@@ -21065,7 +21065,7 @@
       <p:grpSpPr/>
       <p:sp>
         <p:nvSpPr>
-          <p:cNvPr id="2" name="Text: 光明派對  /  青少年團契"/>
+          <p:cNvPr id="2" name="Text: LIGHT PARTY  /  青少年團契"/>
           <p:cNvSpPr txBox="1"/>
           <p:nvPr/>
         </p:nvSpPr>
@@ -21104,7 +21104,7 @@
                 <a:latin typeface="Microsoft JhengHei"/>
                 <a:ea typeface="Microsoft JhengHei"/>
               </a:rPr>
-              <a:t>光明派對  /  青少年團契</a:t>
+              <a:t>LIGHT PARTY  /  青少年團契</a:t>
             </a:r>
           </a:p>
         </p:txBody>
@@ -21506,7 +21506,7 @@
       <p:grpSpPr/>
       <p:sp>
         <p:nvSpPr>
-          <p:cNvPr id="2" name="Text: 光明派對  /  青少年團契"/>
+          <p:cNvPr id="2" name="Text: LIGHT PARTY  /  青少年團契"/>
           <p:cNvSpPr txBox="1"/>
           <p:nvPr/>
         </p:nvSpPr>
@@ -21545,7 +21545,7 @@
                 <a:latin typeface="Microsoft JhengHei"/>
                 <a:ea typeface="Microsoft JhengHei"/>
               </a:rPr>
-              <a:t>光明派對  /  青少年團契</a:t>
+              <a:t>LIGHT PARTY  /  青少年團契</a:t>
             </a:r>
           </a:p>
         </p:txBody>
@@ -21852,7 +21852,7 @@
       </p:sp>
       <p:sp>
         <p:nvSpPr>
-          <p:cNvPr id="10" name="Text: 歷史資料｜萬聖節歷史簡介 ↗"/>
+          <p:cNvPr id="10" name="Text: HISTORY｜History of Halloween ↗"/>
           <p:cNvSpPr txBox="1"/>
           <p:nvPr/>
         </p:nvSpPr>
@@ -21892,7 +21892,7 @@
                 <a:ea typeface="Microsoft JhengHei"/>
                 <a:hlinkClick r:id="rId2"/>
               </a:rPr>
-              <a:t>歷史資料｜萬聖節歷史簡介 ↗</a:t>
+              <a:t>HISTORY｜History of Halloween ↗</a:t>
             </a:r>
           </a:p>
         </p:txBody>
@@ -21946,7 +21946,7 @@
       </p:sp>
       <p:sp>
         <p:nvSpPr>
-          <p:cNvPr id="12" name="Text: 歸藏簡報設計範本｜設計同 HTML 模板 ↗"/>
+          <p:cNvPr id="12" name="Text: Guizang PPT Skill｜設計同 HTML 模板 ↗"/>
           <p:cNvSpPr txBox="1"/>
           <p:nvPr/>
         </p:nvSpPr>
@@ -21986,7 +21986,7 @@
                 <a:ea typeface="Microsoft JhengHei"/>
                 <a:hlinkClick r:id="rId3"/>
               </a:rPr>
-              <a:t>歸藏簡報設計範本｜設計同 HTML 模板 ↗</a:t>
+              <a:t>Guizang PPT Skill｜設計同 HTML 模板 ↗</a:t>
             </a:r>
           </a:p>
         </p:txBody>
@@ -22204,7 +22204,7 @@
       <p:grpSpPr/>
       <p:sp>
         <p:nvSpPr>
-          <p:cNvPr id="2" name="Text: 光明派對  /  青少年團契"/>
+          <p:cNvPr id="2" name="Text: LIGHT PARTY  /  青少年團契"/>
           <p:cNvSpPr txBox="1"/>
           <p:nvPr/>
         </p:nvSpPr>
@@ -22243,7 +22243,7 @@
                 <a:latin typeface="Microsoft JhengHei"/>
                 <a:ea typeface="Microsoft JhengHei"/>
               </a:rPr>
-              <a:t>光明派對  /  青少年團契</a:t>
+              <a:t>LIGHT PARTY  /  青少年團契</a:t>
             </a:r>
           </a:p>
         </p:txBody>
@@ -23164,7 +23164,7 @@
       <p:grpSpPr/>
       <p:sp>
         <p:nvSpPr>
-          <p:cNvPr id="2" name="Text: 光明派對  /  青少年團契"/>
+          <p:cNvPr id="2" name="Text: LIGHT PARTY  /  青少年團契"/>
           <p:cNvSpPr txBox="1"/>
           <p:nvPr/>
         </p:nvSpPr>
@@ -23203,7 +23203,7 @@
                 <a:latin typeface="Microsoft JhengHei"/>
                 <a:ea typeface="Microsoft JhengHei"/>
               </a:rPr>
-              <a:t>光明派對  /  青少年團契</a:t>
+              <a:t>LIGHT PARTY  /  青少年團契</a:t>
             </a:r>
           </a:p>
         </p:txBody>
@@ -23372,7 +23372,7 @@
       </p:sp>
       <p:sp>
         <p:nvSpPr>
-          <p:cNvPr id="7" name="Text: 真假挑戰  /  問題 01"/>
+          <p:cNvPr id="7" name="Text: 真假挑戰  /  QUESTION 01"/>
           <p:cNvSpPr txBox="1"/>
           <p:nvPr/>
         </p:nvSpPr>
@@ -23411,14 +23411,14 @@
                 <a:latin typeface="Microsoft JhengHei"/>
                 <a:ea typeface="Microsoft JhengHei"/>
               </a:rPr>
-              <a:t>真假挑戰  /  問題 01</a:t>
-            </a:r>
-          </a:p>
-        </p:txBody>
-      </p:sp>
-      <p:sp>
-        <p:nvSpPr>
-          <p:cNvPr id="8" name="Text: 「唔畀糖，就搞搞震」一開始，&#10;係咪為咗攞朱古力？"/>
+              <a:t>真假挑戰  /  QUESTION 01</a:t>
+            </a:r>
+          </a:p>
+        </p:txBody>
+      </p:sp>
+      <p:sp>
+        <p:nvSpPr>
+          <p:cNvPr id="8" name="Text: 「Trick or Treat」一開始，&#10;就係為咗攞朱古力？"/>
           <p:cNvSpPr txBox="1"/>
           <p:nvPr/>
         </p:nvSpPr>
@@ -23457,7 +23457,7 @@
                 <a:latin typeface="PMingLiU"/>
                 <a:ea typeface="PMingLiU"/>
               </a:rPr>
-              <a:t>「唔畀糖，就搞搞震」一開始，</a:t>
+              <a:t>「Trick or Treat」一開始，</a:t>
             </a:r>
           </a:p>
           <a:p>
@@ -23480,7 +23480,7 @@
                 <a:latin typeface="PMingLiU"/>
                 <a:ea typeface="PMingLiU"/>
               </a:rPr>
-              <a:t>係咪為咗攞朱古力？</a:t>
+              <a:t>就係為咗攞朱古力？</a:t>
             </a:r>
           </a:p>
         </p:txBody>
@@ -23522,7 +23522,7 @@
       </p:cxnSp>
       <p:sp>
         <p:nvSpPr>
-          <p:cNvPr id="10" name="Text: 真"/>
+          <p:cNvPr id="10" name="Text: 真 TRUE"/>
           <p:cNvSpPr txBox="1"/>
           <p:nvPr/>
         </p:nvSpPr>
@@ -23561,7 +23561,7 @@
                 <a:latin typeface="PMingLiU"/>
                 <a:ea typeface="PMingLiU"/>
               </a:rPr>
-              <a:t>真</a:t>
+              <a:t>真 TRUE</a:t>
             </a:r>
           </a:p>
         </p:txBody>
@@ -23614,7 +23614,7 @@
       </p:sp>
       <p:sp>
         <p:nvSpPr>
-          <p:cNvPr id="12" name="Text: 假"/>
+          <p:cNvPr id="12" name="Text: 假 FALSE"/>
           <p:cNvSpPr txBox="1"/>
           <p:nvPr/>
         </p:nvSpPr>
@@ -23653,7 +23653,7 @@
                 <a:latin typeface="PMingLiU"/>
                 <a:ea typeface="PMingLiU"/>
               </a:rPr>
-              <a:t>假</a:t>
+              <a:t>假 FALSE</a:t>
             </a:r>
           </a:p>
         </p:txBody>
@@ -23732,7 +23732,7 @@
       <p:grpSpPr/>
       <p:sp>
         <p:nvSpPr>
-          <p:cNvPr id="2" name="Text: 光明派對  /  青少年團契"/>
+          <p:cNvPr id="2" name="Text: LIGHT PARTY  /  青少年團契"/>
           <p:cNvSpPr txBox="1"/>
           <p:nvPr/>
         </p:nvSpPr>
@@ -23771,7 +23771,7 @@
                 <a:latin typeface="Microsoft JhengHei"/>
                 <a:ea typeface="Microsoft JhengHei"/>
               </a:rPr>
-              <a:t>光明派對  /  青少年團契</a:t>
+              <a:t>LIGHT PARTY  /  青少年團契</a:t>
             </a:r>
           </a:p>
         </p:txBody>
@@ -24101,7 +24101,7 @@
       </p:sp>
       <p:sp>
         <p:nvSpPr>
-          <p:cNvPr id="10" name="Text: 有啲人會為亡者祈禱，換取「靈魂餅」；&#10;亦有人化裝上門表演，換取食"/>
+          <p:cNvPr id="10" name="Text: 相關前身包括祈禱換取「靈魂餅」，&#10;同埋裝扮表演換取食物或小禮物。"/>
           <p:cNvSpPr txBox="1"/>
           <p:nvPr/>
         </p:nvSpPr>
@@ -24140,7 +24140,7 @@
                 <a:latin typeface="Microsoft JhengHei"/>
                 <a:ea typeface="Microsoft JhengHei"/>
               </a:rPr>
-              <a:t>有啲人會為亡者祈禱，換取「靈魂餅」；</a:t>
+              <a:t>相關前身包括祈禱換取「靈魂餅」，</a:t>
             </a:r>
           </a:p>
           <a:p>
@@ -24163,7 +24163,7 @@
                 <a:latin typeface="Microsoft JhengHei"/>
                 <a:ea typeface="Microsoft JhengHei"/>
               </a:rPr>
-              <a:t>亦有人化裝上門表演，換取食物或小禮物。</a:t>
+              <a:t>同埋裝扮表演換取食物或小禮物。</a:t>
             </a:r>
           </a:p>
           <a:p>
@@ -24186,14 +24186,14 @@
                 <a:latin typeface="Microsoft JhengHei"/>
                 <a:ea typeface="Microsoft JhengHei"/>
               </a:rPr>
-              <a:t>今日嘅討糖果習俗由唔同文化慢慢演變而成。</a:t>
-            </a:r>
-          </a:p>
-        </p:txBody>
-      </p:sp>
-      <p:sp>
-        <p:nvSpPr>
-          <p:cNvPr id="11" name="Text: 歷史參考：歷史資料｜萬聖節歷史簡介"/>
+              <a:t>現代討糖果由多種習俗慢慢演變。</a:t>
+            </a:r>
+          </a:p>
+        </p:txBody>
+      </p:sp>
+      <p:sp>
+        <p:nvSpPr>
+          <p:cNvPr id="11" name="Text: 歷史參考：HISTORY｜History of Hallowee"/>
           <p:cNvSpPr txBox="1"/>
           <p:nvPr/>
         </p:nvSpPr>
@@ -24232,7 +24232,7 @@
                 <a:latin typeface="Microsoft JhengHei"/>
                 <a:ea typeface="Microsoft JhengHei"/>
               </a:rPr>
-              <a:t>歷史參考：歷史資料｜萬聖節歷史簡介</a:t>
+              <a:t>歷史參考：HISTORY｜History of Halloween</a:t>
             </a:r>
           </a:p>
         </p:txBody>
@@ -24265,7 +24265,7 @@
       <p:grpSpPr/>
       <p:sp>
         <p:nvSpPr>
-          <p:cNvPr id="2" name="Text: 光明派對  /  青少年團契"/>
+          <p:cNvPr id="2" name="Text: LIGHT PARTY  /  青少年團契"/>
           <p:cNvSpPr txBox="1"/>
           <p:nvPr/>
         </p:nvSpPr>
@@ -24304,7 +24304,7 @@
                 <a:latin typeface="Microsoft JhengHei"/>
                 <a:ea typeface="Microsoft JhengHei"/>
               </a:rPr>
-              <a:t>光明派對  /  青少年團契</a:t>
+              <a:t>LIGHT PARTY  /  青少年團契</a:t>
             </a:r>
           </a:p>
         </p:txBody>
@@ -24473,7 +24473,7 @@
       </p:sp>
       <p:sp>
         <p:nvSpPr>
-          <p:cNvPr id="7" name="Text: 真假挑戰  /  問題 02"/>
+          <p:cNvPr id="7" name="Text: 真假挑戰  /  QUESTION 02"/>
           <p:cNvSpPr txBox="1"/>
           <p:nvPr/>
         </p:nvSpPr>
@@ -24512,14 +24512,14 @@
                 <a:latin typeface="Microsoft JhengHei"/>
                 <a:ea typeface="Microsoft JhengHei"/>
               </a:rPr>
-              <a:t>真假挑戰  /  問題 02</a:t>
-            </a:r>
-          </a:p>
-        </p:txBody>
-      </p:sp>
-      <p:sp>
-        <p:nvSpPr>
-          <p:cNvPr id="8" name="Text: 傑克燈，&#10;最早係用南瓜做嘅？"/>
+              <a:t>真假挑戰  /  QUESTION 02</a:t>
+            </a:r>
+          </a:p>
+        </p:txBody>
+      </p:sp>
+      <p:sp>
+        <p:nvSpPr>
+          <p:cNvPr id="8" name="Text: Jack-o'-lantern，&#10;最早就係用南瓜做嘅？"/>
           <p:cNvSpPr txBox="1"/>
           <p:nvPr/>
         </p:nvSpPr>
@@ -24558,7 +24558,7 @@
                 <a:latin typeface="PMingLiU"/>
                 <a:ea typeface="PMingLiU"/>
               </a:rPr>
-              <a:t>傑克燈，</a:t>
+              <a:t>Jack-o'-lantern，</a:t>
             </a:r>
           </a:p>
           <a:p>
@@ -24581,7 +24581,7 @@
                 <a:latin typeface="PMingLiU"/>
                 <a:ea typeface="PMingLiU"/>
               </a:rPr>
-              <a:t>最早係用南瓜做嘅？</a:t>
+              <a:t>最早就係用南瓜做嘅？</a:t>
             </a:r>
           </a:p>
         </p:txBody>
@@ -24623,7 +24623,7 @@
       </p:cxnSp>
       <p:sp>
         <p:nvSpPr>
-          <p:cNvPr id="10" name="Text: 真"/>
+          <p:cNvPr id="10" name="Text: 真 TRUE"/>
           <p:cNvSpPr txBox="1"/>
           <p:nvPr/>
         </p:nvSpPr>
@@ -24662,7 +24662,7 @@
                 <a:latin typeface="PMingLiU"/>
                 <a:ea typeface="PMingLiU"/>
               </a:rPr>
-              <a:t>真</a:t>
+              <a:t>真 TRUE</a:t>
             </a:r>
           </a:p>
         </p:txBody>
@@ -24715,7 +24715,7 @@
       </p:sp>
       <p:sp>
         <p:nvSpPr>
-          <p:cNvPr id="12" name="Text: 假"/>
+          <p:cNvPr id="12" name="Text: 假 FALSE"/>
           <p:cNvSpPr txBox="1"/>
           <p:nvPr/>
         </p:nvSpPr>
@@ -24754,7 +24754,7 @@
                 <a:latin typeface="PMingLiU"/>
                 <a:ea typeface="PMingLiU"/>
               </a:rPr>
-              <a:t>假</a:t>
+              <a:t>假 FALSE</a:t>
             </a:r>
           </a:p>
         </p:txBody>
@@ -24833,7 +24833,7 @@
       <p:grpSpPr/>
       <p:sp>
         <p:nvSpPr>
-          <p:cNvPr id="2" name="Text: 光明派對  /  青少年團契"/>
+          <p:cNvPr id="2" name="Text: LIGHT PARTY  /  青少年團契"/>
           <p:cNvSpPr txBox="1"/>
           <p:nvPr/>
         </p:nvSpPr>
@@ -24872,7 +24872,7 @@
                 <a:latin typeface="Microsoft JhengHei"/>
                 <a:ea typeface="Microsoft JhengHei"/>
               </a:rPr>
-              <a:t>光明派對  /  青少年團契</a:t>
+              <a:t>LIGHT PARTY  /  青少年團契</a:t>
             </a:r>
           </a:p>
         </p:txBody>
@@ -25366,7 +25366,7 @@
       <p:grpSpPr/>
       <p:sp>
         <p:nvSpPr>
-          <p:cNvPr id="2" name="Text: 光明派對  /  青少年團契"/>
+          <p:cNvPr id="2" name="Text: LIGHT PARTY  /  青少年團契"/>
           <p:cNvSpPr txBox="1"/>
           <p:nvPr/>
         </p:nvSpPr>
@@ -25405,7 +25405,7 @@
                 <a:latin typeface="Microsoft JhengHei"/>
                 <a:ea typeface="Microsoft JhengHei"/>
               </a:rPr>
-              <a:t>光明派對  /  青少年團契</a:t>
+              <a:t>LIGHT PARTY  /  青少年團契</a:t>
             </a:r>
           </a:p>
         </p:txBody>
@@ -25574,7 +25574,7 @@
       </p:sp>
       <p:sp>
         <p:nvSpPr>
-          <p:cNvPr id="7" name="Text: 真假挑戰  /  問題 03"/>
+          <p:cNvPr id="7" name="Text: 真假挑戰  /  QUESTION 03"/>
           <p:cNvSpPr txBox="1"/>
           <p:nvPr/>
         </p:nvSpPr>
@@ -25613,7 +25613,7 @@
                 <a:latin typeface="Microsoft JhengHei"/>
                 <a:ea typeface="Microsoft JhengHei"/>
               </a:rPr>
-              <a:t>真假挑戰  /  問題 03</a:t>
+              <a:t>真假挑戰  /  QUESTION 03</a:t>
             </a:r>
           </a:p>
         </p:txBody>
@@ -25724,7 +25724,7 @@
       </p:cxnSp>
       <p:sp>
         <p:nvSpPr>
-          <p:cNvPr id="10" name="Text: 真"/>
+          <p:cNvPr id="10" name="Text: 真 TRUE"/>
           <p:cNvSpPr txBox="1"/>
           <p:nvPr/>
         </p:nvSpPr>
@@ -25763,7 +25763,7 @@
                 <a:latin typeface="PMingLiU"/>
                 <a:ea typeface="PMingLiU"/>
               </a:rPr>
-              <a:t>真</a:t>
+              <a:t>真 TRUE</a:t>
             </a:r>
           </a:p>
         </p:txBody>
@@ -25816,7 +25816,7 @@
       </p:sp>
       <p:sp>
         <p:nvSpPr>
-          <p:cNvPr id="12" name="Text: 假"/>
+          <p:cNvPr id="12" name="Text: 假 FALSE"/>
           <p:cNvSpPr txBox="1"/>
           <p:nvPr/>
         </p:nvSpPr>
@@ -25855,7 +25855,7 @@
                 <a:latin typeface="PMingLiU"/>
                 <a:ea typeface="PMingLiU"/>
               </a:rPr>
-              <a:t>假</a:t>
+              <a:t>假 FALSE</a:t>
             </a:r>
           </a:p>
         </p:txBody>
@@ -25934,7 +25934,7 @@
       <p:grpSpPr/>
       <p:sp>
         <p:nvSpPr>
-          <p:cNvPr id="2" name="Text: 光明派對  /  青少年團契"/>
+          <p:cNvPr id="2" name="Text: LIGHT PARTY  /  青少年團契"/>
           <p:cNvSpPr txBox="1"/>
           <p:nvPr/>
         </p:nvSpPr>
@@ -25973,7 +25973,7 @@
                 <a:latin typeface="Microsoft JhengHei"/>
                 <a:ea typeface="Microsoft JhengHei"/>
               </a:rPr>
-              <a:t>光明派對  /  青少年團契</a:t>
+              <a:t>LIGHT PARTY  /  青少年團契</a:t>
             </a:r>
           </a:p>
         </p:txBody>
@@ -26303,7 +26303,7 @@
       </p:sp>
       <p:sp>
         <p:nvSpPr>
-          <p:cNvPr id="10" name="Text: 薩溫節係重要歷史背景之一。&#10;時間大約係 10 月 31 日至 1"/>
+          <p:cNvPr id="10" name="Text: 薩溫節（Samhain）係重要歷史背景之一。&#10;時間大約係 10 "/>
           <p:cNvSpPr txBox="1"/>
           <p:nvPr/>
         </p:nvSpPr>
@@ -26342,7 +26342,7 @@
                 <a:latin typeface="Microsoft JhengHei"/>
                 <a:ea typeface="Microsoft JhengHei"/>
               </a:rPr>
-              <a:t>薩溫節係重要歷史背景之一。</a:t>
+              <a:t>薩溫節（Samhain）係重要歷史背景之一。</a:t>
             </a:r>
           </a:p>
           <a:p>
@@ -26388,7 +26388,7 @@
                 <a:latin typeface="Microsoft JhengHei"/>
                 <a:ea typeface="Microsoft JhengHei"/>
               </a:rPr>
-              <a:t>唔係冬至前夕，亦唔係萬聖節唯一嘅來源。</a:t>
+              <a:t>唔係冬至前夕；都唔係萬聖節嘅唯一來源。</a:t>
             </a:r>
           </a:p>
         </p:txBody>

</xml_diff>

<commit_message>
Remove safety reminder from page 24
Co-authored-by: Copilot App <223556219+Copilot@users.noreply.github.com>
</commit_message>
<xml_diff>
--- a/light-party.pptx
+++ b/light-party.pptx
@@ -19802,53 +19802,7 @@
       </p:sp>
       <p:sp>
         <p:nvSpPr>
-          <p:cNvPr id="11" name="Text: 留意食物過敏；螢光棒唔拆開、唔咬破；保持走道暢通。"/>
-          <p:cNvSpPr txBox="1"/>
-          <p:nvPr/>
-        </p:nvSpPr>
-        <p:spPr>
-          <a:xfrm>
-            <a:off x="731520" y="5577840"/>
-            <a:ext cx="10725912" cy="384048"/>
-          </a:xfrm>
-          <a:prstGeom prst="rect">
-            <a:avLst/>
-          </a:prstGeom>
-          <a:noFill/>
-        </p:spPr>
-        <p:txBody>
-          <a:bodyPr wrap="square" lIns="0" rIns="0" tIns="0" bIns="0" anchor="t">
-            <a:spAutoFit/>
-          </a:bodyPr>
-          <a:lstStyle/>
-          <a:p>
-            <a:pPr algn="l">
-              <a:lnSpc>
-                <a:spcPct val="118000"/>
-              </a:lnSpc>
-              <a:spcBef>
-                <a:spcPts val="0"/>
-              </a:spcBef>
-              <a:spcAft>
-                <a:spcPts val="0"/>
-              </a:spcAft>
-            </a:pPr>
-            <a:r>
-              <a:rPr sz="1700" b="0" lang="zh-HK">
-                <a:solidFill>
-                  <a:srgbClr val="6A513D"/>
-                </a:solidFill>
-                <a:latin typeface="Microsoft JhengHei"/>
-                <a:ea typeface="Microsoft JhengHei"/>
-              </a:rPr>
-              <a:t>留意食物過敏；螢光棒唔拆開、唔咬破；保持走道暢通。</a:t>
-            </a:r>
-          </a:p>
-        </p:txBody>
-      </p:sp>
-      <p:sp>
-        <p:nvSpPr>
-          <p:cNvPr id="12" name="Oval 11"/>
+          <p:cNvPr id="11" name="Oval 10"/>
           <p:cNvSpPr/>
           <p:nvPr/>
         </p:nvSpPr>
@@ -19891,7 +19845,7 @@
       </p:sp>
       <p:sp>
         <p:nvSpPr>
-          <p:cNvPr id="13" name="Oval 12"/>
+          <p:cNvPr id="12" name="Oval 11"/>
           <p:cNvSpPr/>
           <p:nvPr/>
         </p:nvSpPr>
@@ -19934,7 +19888,7 @@
       </p:sp>
       <p:sp>
         <p:nvSpPr>
-          <p:cNvPr id="14" name="Oval 13"/>
+          <p:cNvPr id="13" name="Oval 12"/>
           <p:cNvSpPr/>
           <p:nvPr/>
         </p:nvSpPr>
@@ -19977,7 +19931,7 @@
       </p:sp>
       <p:sp>
         <p:nvSpPr>
-          <p:cNvPr id="15" name="Oval 14"/>
+          <p:cNvPr id="14" name="Oval 13"/>
           <p:cNvSpPr/>
           <p:nvPr/>
         </p:nvSpPr>
@@ -20020,14 +19974,49 @@
       </p:sp>
       <p:cxnSp>
         <p:nvCxnSpPr>
+          <p:cNvPr id="15" name="Connector 14"/>
+          <p:cNvCxnSpPr/>
+          <p:nvPr/>
+        </p:nvCxnSpPr>
+        <p:spPr>
+          <a:xfrm>
+            <a:off x="10252252" y="2779776"/>
+            <a:ext cx="135185" cy="0"/>
+          </a:xfrm>
+          <a:prstGeom prst="line">
+            <a:avLst/>
+          </a:prstGeom>
+          <a:ln w="17780">
+            <a:solidFill>
+              <a:srgbClr val="804212"/>
+            </a:solidFill>
+          </a:ln>
+        </p:spPr>
+        <p:style>
+          <a:lnRef idx="2">
+            <a:schemeClr val="accent1"/>
+          </a:lnRef>
+          <a:fillRef idx="0">
+            <a:schemeClr val="accent1"/>
+          </a:fillRef>
+          <a:effectRef idx="1">
+            <a:schemeClr val="accent1"/>
+          </a:effectRef>
+          <a:fontRef idx="minor">
+            <a:schemeClr val="tx1"/>
+          </a:fontRef>
+        </p:style>
+      </p:cxnSp>
+      <p:cxnSp>
+        <p:nvCxnSpPr>
           <p:cNvPr id="16" name="Connector 15"/>
           <p:cNvCxnSpPr/>
           <p:nvPr/>
         </p:nvCxnSpPr>
         <p:spPr>
           <a:xfrm>
-            <a:off x="10252252" y="2779776"/>
-            <a:ext cx="135185" cy="0"/>
+            <a:off x="10072276" y="3214276"/>
+            <a:ext cx="95590" cy="95590"/>
           </a:xfrm>
           <a:prstGeom prst="line">
             <a:avLst/>
@@ -20061,8 +20050,8 @@
         </p:nvCxnSpPr>
         <p:spPr>
           <a:xfrm>
-            <a:off x="10072276" y="3214276"/>
-            <a:ext cx="95590" cy="95590"/>
+            <a:off x="9637776" y="3394252"/>
+            <a:ext cx="0" cy="135185"/>
           </a:xfrm>
           <a:prstGeom prst="line">
             <a:avLst/>
@@ -20095,9 +20084,9 @@
           <p:nvPr/>
         </p:nvCxnSpPr>
         <p:spPr>
-          <a:xfrm>
-            <a:off x="9637776" y="3394252"/>
-            <a:ext cx="0" cy="135185"/>
+          <a:xfrm flipH="1">
+            <a:off x="9107685" y="3214276"/>
+            <a:ext cx="95590" cy="95590"/>
           </a:xfrm>
           <a:prstGeom prst="line">
             <a:avLst/>
@@ -20131,8 +20120,8 @@
         </p:nvCxnSpPr>
         <p:spPr>
           <a:xfrm flipH="1">
-            <a:off x="9107685" y="3214276"/>
-            <a:ext cx="95590" cy="95590"/>
+            <a:off x="8888114" y="2779776"/>
+            <a:ext cx="135185" cy="0"/>
           </a:xfrm>
           <a:prstGeom prst="line">
             <a:avLst/>
@@ -20165,9 +20154,9 @@
           <p:nvPr/>
         </p:nvCxnSpPr>
         <p:spPr>
-          <a:xfrm flipH="1">
-            <a:off x="8888114" y="2779776"/>
-            <a:ext cx="135185" cy="0"/>
+          <a:xfrm flipH="1" flipV="1">
+            <a:off x="9107685" y="2249685"/>
+            <a:ext cx="95590" cy="95590"/>
           </a:xfrm>
           <a:prstGeom prst="line">
             <a:avLst/>
@@ -20200,9 +20189,9 @@
           <p:nvPr/>
         </p:nvCxnSpPr>
         <p:spPr>
-          <a:xfrm flipH="1" flipV="1">
-            <a:off x="9107685" y="2249685"/>
-            <a:ext cx="95590" cy="95590"/>
+          <a:xfrm flipV="1">
+            <a:off x="9637776" y="2030114"/>
+            <a:ext cx="0" cy="135185"/>
           </a:xfrm>
           <a:prstGeom prst="line">
             <a:avLst/>
@@ -20231,41 +20220,6 @@
       <p:cxnSp>
         <p:nvCxnSpPr>
           <p:cNvPr id="22" name="Connector 21"/>
-          <p:cNvCxnSpPr/>
-          <p:nvPr/>
-        </p:nvCxnSpPr>
-        <p:spPr>
-          <a:xfrm flipV="1">
-            <a:off x="9637776" y="2030114"/>
-            <a:ext cx="0" cy="135185"/>
-          </a:xfrm>
-          <a:prstGeom prst="line">
-            <a:avLst/>
-          </a:prstGeom>
-          <a:ln w="17780">
-            <a:solidFill>
-              <a:srgbClr val="804212"/>
-            </a:solidFill>
-          </a:ln>
-        </p:spPr>
-        <p:style>
-          <a:lnRef idx="2">
-            <a:schemeClr val="accent1"/>
-          </a:lnRef>
-          <a:fillRef idx="0">
-            <a:schemeClr val="accent1"/>
-          </a:fillRef>
-          <a:effectRef idx="1">
-            <a:schemeClr val="accent1"/>
-          </a:effectRef>
-          <a:fontRef idx="minor">
-            <a:schemeClr val="tx1"/>
-          </a:fontRef>
-        </p:style>
-      </p:cxnSp>
-      <p:cxnSp>
-        <p:nvCxnSpPr>
-          <p:cNvPr id="23" name="Connector 22"/>
           <p:cNvCxnSpPr/>
           <p:nvPr/>
         </p:nvCxnSpPr>

</xml_diff>